<commit_message>
docs: live demo link in README and deck, CI runs tests only
</commit_message>
<xml_diff>
--- a/deck/NoticeDecoder_NovaNexus_PS02.pptx
+++ b/deck/NoticeDecoder_NovaNexus_PS02.pptx
@@ -3835,55 +3835,37 @@
           </a:p>
         </p:txBody>
       </p:sp>
-      <p:sp>
-        <p:nvSpPr>
-          <p:cNvPr id="16" name="Rounded Rectangle 15"/>
-          <p:cNvSpPr/>
-          <p:nvPr/>
-        </p:nvSpPr>
-        <p:spPr>
-          <a:xfrm>
-            <a:off x="7818120" y="4846320"/>
-            <a:ext cx="3867912" cy="1417320"/>
-          </a:xfrm>
-          <a:prstGeom prst="roundRect">
-            <a:avLst>
-              <a:gd name="adj" fmla="val 6000"/>
-            </a:avLst>
-          </a:prstGeom>
-          <a:solidFill>
-            <a:srgbClr val="FFFFFF"/>
-          </a:solidFill>
-          <a:ln w="12700">
+      <p:pic>
+        <p:nvPicPr>
+          <p:cNvPr id="16" name="Picture 15" descr="qr-live.png">
+            <a:hlinkClick r:id="rId3"/>
+          </p:cNvPr>
+          <p:cNvPicPr>
+            <a:picLocks noChangeAspect="1"/>
+          </p:cNvPicPr>
+          <p:nvPr/>
+        </p:nvPicPr>
+        <p:blipFill>
+          <a:blip r:embed="rId2"/>
+          <a:stretch>
+            <a:fillRect/>
+          </a:stretch>
+        </p:blipFill>
+        <p:spPr>
+          <a:xfrm>
+            <a:off x="8001000" y="4773168"/>
+            <a:ext cx="1325880" cy="1325880"/>
+          </a:xfrm>
+          <a:prstGeom prst="rect">
+            <a:avLst/>
+          </a:prstGeom>
+          <a:ln w="9525">
             <a:solidFill>
               <a:srgbClr val="D5D8E3"/>
             </a:solidFill>
-            <a:prstDash val="dash"/>
           </a:ln>
-          <a:effectLst/>
-        </p:spPr>
-        <p:style>
-          <a:lnRef idx="1">
-            <a:schemeClr val="accent1"/>
-          </a:lnRef>
-          <a:fillRef idx="3">
-            <a:schemeClr val="accent1"/>
-          </a:fillRef>
-          <a:effectRef idx="2">
-            <a:schemeClr val="accent1"/>
-          </a:effectRef>
-          <a:fontRef idx="minor">
-            <a:schemeClr val="lt1"/>
-          </a:fontRef>
-        </p:style>
-        <p:txBody>
-          <a:bodyPr rtlCol="0" anchor="ctr"/>
-          <a:lstStyle/>
-          <a:p>
-            <a:pPr algn="ctr"/>
-          </a:p>
-        </p:txBody>
-      </p:sp>
+        </p:spPr>
+      </p:pic>
       <p:sp>
         <p:nvSpPr>
           <p:cNvPr id="17" name="TextBox 16"/>
@@ -3892,8 +3874,8 @@
         </p:nvSpPr>
         <p:spPr>
           <a:xfrm>
-            <a:off x="7955279" y="4956048"/>
-            <a:ext cx="3611880" cy="1188720"/>
+            <a:off x="9464040" y="4846320"/>
+            <a:ext cx="2286000" cy="1280160"/>
           </a:xfrm>
           <a:prstGeom prst="rect">
             <a:avLst/>
@@ -3901,14 +3883,14 @@
           <a:noFill/>
         </p:spPr>
         <p:txBody>
-          <a:bodyPr wrap="square" anchor="ctr" lIns="45720" rIns="45720" tIns="27432" bIns="27432">
+          <a:bodyPr wrap="square" anchor="t" lIns="45720" rIns="45720" tIns="27432" bIns="27432">
             <a:spAutoFit/>
           </a:bodyPr>
           <a:lstStyle/>
           <a:p>
-            <a:pPr algn="ctr">
+            <a:pPr algn="l">
               <a:spcAft>
-                <a:spcPts val="600"/>
+                <a:spcPts val="200"/>
               </a:spcAft>
             </a:pPr>
             <a:r>
@@ -3922,19 +3904,34 @@
             </a:r>
           </a:p>
           <a:p>
-            <a:pPr algn="ctr">
+            <a:pPr algn="l">
               <a:spcAft>
-                <a:spcPts val="600"/>
+                <a:spcPts val="200"/>
               </a:spcAft>
             </a:pPr>
             <a:r>
               <a:rPr sz="1400" b="0">
                 <a:solidFill>
-                  <a:srgbClr val="5E6070"/>
-                </a:solidFill>
-                <a:latin typeface="Arial"/>
-              </a:rPr>
-              <a:t>QR code and link go here after deploy</a:t>
+                  <a:srgbClr val="22222E"/>
+                </a:solidFill>
+                <a:latin typeface="Arial"/>
+              </a:rPr>
+              <a:t>Scan, or open:</a:t>
+            </a:r>
+          </a:p>
+          <a:p>
+            <a:r>
+              <a:rPr sz="1300" b="1">
+                <a:solidFill>
+                  <a:srgbClr val="0033EE"/>
+                </a:solidFill>
+                <a:latin typeface="Arial"/>
+                <a:hlinkClick r:id="rId3"/>
+              </a:rPr>
+              <a:t>anki1kr.me/NoticeDecoder/app</a:t>
+            </a:r>
+            <a:r>
+              <a:t> </a:t>
             </a:r>
           </a:p>
         </p:txBody>

</xml_diff>

<commit_message>
Messy input handled, deck marked as the Round 2 prototype
- engine: a day that does not exist ("31 Feb") is dropped, so the card asks for a date instead of exporting it
- engine: invisible characters and WhatsApp copy prefixes ("[05/10/26, 9:14 AM] Rahul: ") are removed before
  reading; parseNotice returns the cleaned text and the page highlights into it
- test for all three; bundles regenerated; sw.js VERSION nd-v15
- CI: the workflow file is valid YAML again (an unquoted "run: ..." inside a run line broke it)
- deck: footer says Prototype Submission; slide 2 lists what other notice tools do not have
</commit_message>
<xml_diff>
--- a/deck/NoticeDecoder_NovaNexus_PS02.pptx
+++ b/deck/NoticeDecoder_NovaNexus_PS02.pptx
@@ -5657,7 +5657,7 @@
                   <a:schemeClr val="bg1"/>
                 </a:solidFill>
               </a:rPr>
-              <a:t>@SETU 2026  PS-02 Idea Submission</a:t>
+              <a:t>@SETU 2026  PS-02 Prototype Submission</a:t>
             </a:r>
             <a:endParaRPr lang="en-US" dirty="0">
               <a:solidFill>
@@ -6400,7 +6400,7 @@
                 </a:solidFill>
                 <a:latin typeface="Calibri"/>
               </a:rPr>
-              <a:t>Why it is different</a:t>
+              <a:t>What others will not have</a:t>
             </a:r>
           </a:p>
         </p:txBody>
@@ -6429,101 +6429,101 @@
           <a:p>
             <a:pPr algn="l">
               <a:spcAft>
-                <a:spcPts val="700"/>
+                <a:spcPts val="600"/>
               </a:spcAft>
             </a:pPr>
             <a:r>
-              <a:rPr sz="1400" b="1">
+              <a:rPr sz="1300" b="1">
                 <a:solidFill>
                   <a:srgbClr val="1F497D"/>
                 </a:solidFill>
                 <a:latin typeface="Calibri"/>
               </a:rPr>
-              <a:t>Shows its working.</a:t>
-            </a:r>
-            <a:r>
-              <a:rPr sz="1400" b="0">
+              <a:t>Shows where each date came from.</a:t>
+            </a:r>
+            <a:r>
+              <a:rPr sz="1300" b="0">
                 <a:solidFill>
                   <a:srgbClr val="262A33"/>
                 </a:solidFill>
                 <a:latin typeface="Calibri"/>
               </a:rPr>
-              <a:t> Every date, time and room points to the words it came from.</a:t>
+              <a:t> Tap a date and the notice lights up the words.</a:t>
             </a:r>
           </a:p>
           <a:p>
             <a:pPr algn="l">
               <a:spcAft>
-                <a:spcPts val="700"/>
+                <a:spcPts val="600"/>
               </a:spcAft>
             </a:pPr>
             <a:r>
-              <a:rPr sz="1400" b="1">
+              <a:rPr sz="1300" b="1">
                 <a:solidFill>
                   <a:srgbClr val="1F497D"/>
                 </a:solidFill>
                 <a:latin typeface="Calibri"/>
               </a:rPr>
-              <a:t>Asks when unsure.</a:t>
-            </a:r>
-            <a:r>
-              <a:rPr sz="1400" b="0">
+              <a:t>Catches a notice that disagrees with itself.</a:t>
+            </a:r>
+            <a:r>
+              <a:rPr sz="1300" b="0">
                 <a:solidFill>
                   <a:srgbClr val="262A33"/>
                 </a:solidFill>
                 <a:latin typeface="Calibri"/>
               </a:rPr>
-              <a:t> "Thursday? But 13 Nov 2026 is a Friday."</a:t>
+              <a:t> "Results by 9 PM today" and "results next day": both shown, you pick one.</a:t>
             </a:r>
           </a:p>
           <a:p>
             <a:pPr algn="l">
               <a:spcAft>
-                <a:spcPts val="700"/>
+                <a:spcPts val="600"/>
               </a:spcAft>
             </a:pPr>
             <a:r>
-              <a:rPr sz="1400" b="1">
+              <a:rPr sz="1300" b="1">
                 <a:solidFill>
                   <a:srgbClr val="1F497D"/>
                 </a:solidFill>
                 <a:latin typeface="Calibri"/>
               </a:rPr>
-              <a:t>Finds clashes.</a:t>
-            </a:r>
-            <a:r>
-              <a:rPr sz="1400" b="0">
+              <a:t>Never makes up a date.</a:t>
+            </a:r>
+            <a:r>
+              <a:rPr sz="1300" b="0">
                 <a:solidFill>
                   <a:srgbClr val="262A33"/>
                 </a:solidFill>
                 <a:latin typeface="Calibri"/>
               </a:rPr>
-              <a:t> Two events at once, or a deadline during a class.</a:t>
+              <a:t> "This week or next week" waits in a list, not in your calendar.</a:t>
             </a:r>
           </a:p>
           <a:p>
             <a:pPr algn="l">
               <a:spcAft>
-                <a:spcPts val="700"/>
+                <a:spcPts val="600"/>
               </a:spcAft>
             </a:pPr>
             <a:r>
-              <a:rPr sz="1400" b="1">
+              <a:rPr sz="1300" b="1">
                 <a:solidFill>
                   <a:srgbClr val="1F497D"/>
                 </a:solidFill>
                 <a:latin typeface="Calibri"/>
               </a:rPr>
-              <a:t>No AI.</a:t>
-            </a:r>
-            <a:r>
-              <a:rPr sz="1400" b="0">
+              <a:t>One change updates the whole class.</a:t>
+            </a:r>
+            <a:r>
+              <a:rPr sz="1300" b="0">
                 <a:solidFill>
                   <a:srgbClr val="262A33"/>
                 </a:solidFill>
                 <a:latin typeface="Calibri"/>
               </a:rPr>
-              <a:t> Same answer every time, and the reading happens on the phone.</a:t>
+              <a:t> The class rep publishes once; a postponed exam moves in every student's calendar.</a:t>
             </a:r>
           </a:p>
         </p:txBody>
@@ -6820,7 +6820,7 @@
                   <a:schemeClr val="bg1"/>
                 </a:solidFill>
               </a:rPr>
-              <a:t>@SETU 2026  PS-02 Idea Submission</a:t>
+              <a:t>@SETU 2026  PS-02 Prototype Submission</a:t>
             </a:r>
             <a:endParaRPr lang="en-US" dirty="0">
               <a:solidFill>
@@ -7164,7 +7164,7 @@
                 </a:solidFill>
                 <a:latin typeface="Calibri"/>
               </a:rPr>
-              <a:t> 34 rule tests and 75 browser checks run on every change.</a:t>
+              <a:t> 35 rule tests and 75 browser checks run on every change.</a:t>
             </a:r>
           </a:p>
         </p:txBody>
@@ -8530,7 +8530,7 @@
                 <a:ea typeface="+mn-ea"/>
                 <a:cs typeface="+mn-cs"/>
               </a:rPr>
-              <a:t>@SETU 2026  PS-02 Idea Submission</a:t>
+              <a:t>@SETU 2026  PS-02 Prototype Submission</a:t>
             </a:r>
             <a:endParaRPr kumimoji="0" lang="en-US" sz="1200" b="0" i="0" u="none" strike="noStrike" kern="1200" cap="none" spc="0" normalizeH="0" baseline="0" noProof="0" dirty="0">
               <a:ln>
@@ -9967,7 +9967,7 @@
                 <a:ea typeface="+mn-ea"/>
                 <a:cs typeface="+mn-cs"/>
               </a:rPr>
-              <a:t>@SETU 2026  PS-02 Idea Submission</a:t>
+              <a:t>@SETU 2026  PS-02 Prototype Submission</a:t>
             </a:r>
             <a:endParaRPr kumimoji="0" lang="en-US" sz="1200" b="0" i="0" u="none" strike="noStrike" kern="1200" cap="none" spc="0" normalizeH="0" baseline="0" noProof="0" dirty="0">
               <a:ln>
@@ -11164,7 +11164,7 @@
                 <a:ea typeface="+mn-ea"/>
                 <a:cs typeface="+mn-cs"/>
               </a:rPr>
-              <a:t>@SETU 2026  PS-02 Idea Submission</a:t>
+              <a:t>@SETU 2026  PS-02 Prototype Submission</a:t>
             </a:r>
             <a:endParaRPr kumimoji="0" lang="en-US" sz="1200" b="0" i="0" u="none" strike="noStrike" kern="1200" cap="none" spc="0" normalizeH="0" baseline="0" noProof="0" dirty="0">
               <a:ln>

</xml_diff>